<commit_message>
Update the L8 slides
</commit_message>
<xml_diff>
--- a/M2_L8/slides/lesson08.pptx
+++ b/M2_L8/slides/lesson08.pptx
@@ -5586,7 +5586,7 @@
         <p:spPr>
           <a:xfrm>
             <a:off x="457200" y="1051560"/>
-            <a:ext cx="8229600" cy="1828800"/>
+            <a:ext cx="8229600" cy="2331720"/>
           </a:xfrm>
           <a:prstGeom prst="rect">
             <a:avLst/>
@@ -5611,7 +5611,7 @@
         <p:spPr>
           <a:xfrm>
             <a:off x="566928" y="1143000"/>
-            <a:ext cx="8010144" cy="1645920"/>
+            <a:ext cx="8010144" cy="2148840"/>
           </a:xfrm>
           <a:prstGeom prst="rect">
             <a:avLst/>
@@ -5669,6 +5669,17 @@
               </a:lnSpc>
               <a:buNone/>
             </a:pPr>
+            <a:r>
+              <a:rPr lang="en-US" sz="1200" dirty="0">
+                <a:solidFill>
+                  <a:srgbClr val="A8D8FF"/>
+                </a:solidFill>
+                <a:latin typeface="Consolas" pitchFamily="34" charset="0"/>
+                <a:ea typeface="Consolas" pitchFamily="34" charset="-122"/>
+                <a:cs typeface="Consolas" pitchFamily="34" charset="-120"/>
+              </a:rPr>
+              <a:t>static const uint8_t CHANNEL_RED = 0U;</a:t>
+            </a:r>
             <a:endParaRPr lang="en-US" sz="1200" dirty="0"/>
           </a:p>
           <a:p>
@@ -5678,17 +5689,6 @@
               </a:lnSpc>
               <a:buNone/>
             </a:pPr>
-            <a:r>
-              <a:rPr lang="en-US" sz="1200" dirty="0">
-                <a:solidFill>
-                  <a:srgbClr val="A8D8FF"/>
-                </a:solidFill>
-                <a:latin typeface="Consolas" pitchFamily="34" charset="0"/>
-                <a:ea typeface="Consolas" pitchFamily="34" charset="-122"/>
-                <a:cs typeface="Consolas" pitchFamily="34" charset="-120"/>
-              </a:rPr>
-              <a:t>ledcAttach(PIN_RED, PWM_FREQ_HZ, PWM_BITS);   // once, in begin()</a:t>
-            </a:r>
             <a:endParaRPr lang="en-US" sz="1200" dirty="0"/>
           </a:p>
           <a:p>
@@ -5707,10 +5707,50 @@
                 <a:ea typeface="Consolas" pitchFamily="34" charset="-122"/>
                 <a:cs typeface="Consolas" pitchFamily="34" charset="-120"/>
               </a:rPr>
-              <a:t>ledcWrite(PIN_RED, 128U);                     // any time after that</a:t>
+              <a:t>ledcSetup(CHANNEL_RED, PWM_FREQ_HZ, PWM_BITS);   // once, in begin()</a:t>
             </a:r>
             <a:endParaRPr lang="en-US" sz="1200" dirty="0"/>
           </a:p>
+          <a:p>
+            <a:pPr indent="0" marL="0">
+              <a:lnSpc>
+                <a:spcPct val="100000"/>
+              </a:lnSpc>
+              <a:buNone/>
+            </a:pPr>
+            <a:r>
+              <a:rPr lang="en-US" sz="1200" dirty="0">
+                <a:solidFill>
+                  <a:srgbClr val="A8D8FF"/>
+                </a:solidFill>
+                <a:latin typeface="Consolas" pitchFamily="34" charset="0"/>
+                <a:ea typeface="Consolas" pitchFamily="34" charset="-122"/>
+                <a:cs typeface="Consolas" pitchFamily="34" charset="-120"/>
+              </a:rPr>
+              <a:t>ledcAttachPin(PIN_RED, CHANNEL_RED);             // once, in begin()</a:t>
+            </a:r>
+            <a:endParaRPr lang="en-US" sz="1200" dirty="0"/>
+          </a:p>
+          <a:p>
+            <a:pPr indent="0" marL="0">
+              <a:lnSpc>
+                <a:spcPct val="100000"/>
+              </a:lnSpc>
+              <a:buNone/>
+            </a:pPr>
+            <a:r>
+              <a:rPr lang="en-US" sz="1200" dirty="0">
+                <a:solidFill>
+                  <a:srgbClr val="A8D8FF"/>
+                </a:solidFill>
+                <a:latin typeface="Consolas" pitchFamily="34" charset="0"/>
+                <a:ea typeface="Consolas" pitchFamily="34" charset="-122"/>
+                <a:cs typeface="Consolas" pitchFamily="34" charset="-120"/>
+              </a:rPr>
+              <a:t>ledcWrite(CHANNEL_RED, 128U);                    // any time after that</a:t>
+            </a:r>
+            <a:endParaRPr lang="en-US" sz="1200" dirty="0"/>
+          </a:p>
         </p:txBody>
       </p:sp>
       <p:sp>
@@ -5721,8 +5761,8 @@
         </p:nvSpPr>
         <p:spPr>
           <a:xfrm>
-            <a:off x="457200" y="3108960"/>
-            <a:ext cx="8229600" cy="1280160"/>
+            <a:off x="457200" y="3566160"/>
+            <a:ext cx="8229600" cy="914400"/>
           </a:xfrm>
           <a:prstGeom prst="rect">
             <a:avLst/>
@@ -5750,7 +5790,7 @@
                 <a:ea typeface="Calibri" pitchFamily="34" charset="-122"/>
                 <a:cs typeface="Calibri" pitchFamily="34" charset="-120"/>
               </a:rPr>
-              <a:t>ledcAttach replaces pinMode for that pin</a:t>
+              <a:t>PWM is made by a channel, not by a pin; the chip has six of them</a:t>
             </a:r>
             <a:endParaRPr lang="en-US" sz="1400" dirty="0"/>
           </a:p>
@@ -5771,28 +5811,7 @@
                 <a:ea typeface="Calibri" pitchFamily="34" charset="-122"/>
                 <a:cs typeface="Calibri" pitchFamily="34" charset="-120"/>
               </a:rPr>
-              <a:t>ledcWrite replaces digitalWrite</a:t>
-            </a:r>
-            <a:endParaRPr lang="en-US" sz="1400" dirty="0"/>
-          </a:p>
-          <a:p>
-            <a:pPr marL="342900" indent="-342900">
-              <a:lnSpc>
-                <a:spcPct val="135000"/>
-              </a:lnSpc>
-              <a:buSzPct val="100000"/>
-              <a:buChar char="■"/>
-            </a:pPr>
-            <a:r>
-              <a:rPr lang="en-US" sz="1400" dirty="0">
-                <a:solidFill>
-                  <a:srgbClr val="CADCFC"/>
-                </a:solidFill>
-                <a:latin typeface="Calibri" pitchFamily="34" charset="0"/>
-                <a:ea typeface="Calibri" pitchFamily="34" charset="-122"/>
-                <a:cs typeface="Calibri" pitchFamily="34" charset="-120"/>
-              </a:rPr>
-              <a:t>analogWrite(pin, value) does the same with default settings</a:t>
+              <a:t>ledcAttachPin connects a pin to a channel; ledcWrite talks to the channel</a:t>
             </a:r>
             <a:endParaRPr lang="en-US" sz="1400" dirty="0"/>
           </a:p>
@@ -6097,7 +6116,7 @@
                 <a:ea typeface="Consolas" pitchFamily="34" charset="-122"/>
                 <a:cs typeface="Consolas" pitchFamily="34" charset="-120"/>
               </a:rPr>
-              <a:t>ledcWrite(m_red, PWM_MAX - c.red);</a:t>
+              <a:t>ledcWrite(CHANNEL_RED, PWM_MAX - c.red);</a:t>
             </a:r>
             <a:endParaRPr lang="en-US" sz="1200" dirty="0"/>
           </a:p>
@@ -6645,7 +6664,7 @@
                 <a:ea typeface="Consolas" pitchFamily="34" charset="-122"/>
                 <a:cs typeface="Consolas" pitchFamily="34" charset="-120"/>
               </a:rPr>
-              <a:t>    ledcWrite(m_red,   PWM_MAX - c.red);</a:t>
+              <a:t>    ledcWrite(CHANNEL_RED,   PWM_MAX - c.red);</a:t>
             </a:r>
             <a:endParaRPr lang="en-US" sz="1200" dirty="0"/>
           </a:p>
@@ -6665,7 +6684,7 @@
                 <a:ea typeface="Consolas" pitchFamily="34" charset="-122"/>
                 <a:cs typeface="Consolas" pitchFamily="34" charset="-120"/>
               </a:rPr>
-              <a:t>    ledcWrite(m_green, PWM_MAX - c.green);</a:t>
+              <a:t>    ledcWrite(CHANNEL_GREEN, PWM_MAX - c.green);</a:t>
             </a:r>
             <a:endParaRPr lang="en-US" sz="1200" dirty="0"/>
           </a:p>
@@ -6685,7 +6704,7 @@
                 <a:ea typeface="Consolas" pitchFamily="34" charset="-122"/>
                 <a:cs typeface="Consolas" pitchFamily="34" charset="-120"/>
               </a:rPr>
-              <a:t>    ledcWrite(m_blue,  PWM_MAX - c.blue);</a:t>
+              <a:t>    ledcWrite(CHANNEL_BLUE,  PWM_MAX - c.blue);</a:t>
             </a:r>
             <a:endParaRPr lang="en-US" sz="1200" dirty="0"/>
           </a:p>

</xml_diff>